<commit_message>
Regenerate decks with responsibility-driven T7 logic
Co-authored-by: newmanxiang <newmanxiang@users.noreply.github.com>
</commit_message>
<xml_diff>
--- a/reports/6g-data-fabric-section-3-deck.pptx
+++ b/reports/6g-data-fabric-section-3-deck.pptx
@@ -5344,7 +5344,7 @@
                           <a:latin typeface="WenQuanYi Micro Hei"/>
                           <a:ea typeface="WenQuanYi Micro Hei"/>
                         </a:rPr>
-                        <a:t>中</a:t>
+                        <a:t>A中高 / B低—中</a:t>
                       </a:r>
                     </a:p>
                   </a:txBody>
@@ -5368,7 +5368,7 @@
                           <a:latin typeface="WenQuanYi Micro Hei"/>
                           <a:ea typeface="WenQuanYi Micro Hei"/>
                         </a:rPr>
-                        <a:t>能力服务已有CAMARA/Open Gateway信号，结果型服务尚不成熟</a:t>
+                        <a:t>能力服务已有CAMARA/Open Gateway信号；结果型服务的归因、责任和规模付费尚不成熟</a:t>
                       </a:r>
                     </a:p>
                   </a:txBody>
@@ -11925,7 +11925,7 @@
                 <a:latin typeface="WenQuanYi Micro Hei"/>
                 <a:ea typeface="WenQuanYi Micro Hei"/>
               </a:rPr>
-              <a:t>T7  ·  商业化双路径</a:t>
+              <a:t>T7  ·  责任边界与商业分化</a:t>
             </a:r>
           </a:p>
         </p:txBody>
@@ -11966,7 +11966,7 @@
                 <a:latin typeface="WenQuanYi Micro Hei"/>
                 <a:ea typeface="WenQuanYi Micro Hei"/>
               </a:rPr>
-              <a:t>商业化将分化为“数据/API能力服务”与“结果型服务”两条路径</a:t>
+              <a:t>商业化将沿责任边界分化：能力服务出售可组合输入，结果服务承诺可归因输出</a:t>
             </a:r>
           </a:p>
         </p:txBody>
@@ -12031,7 +12031,7 @@
                 <a:latin typeface="WenQuanYi Micro Hei"/>
                 <a:ea typeface="WenQuanYi Micro Hei"/>
               </a:rPr>
-              <a:t>外部服务一致性上限由内部产品稳定性决定。能力型服务可先行；结果型服务额外依赖可审计、可约束、可回滚的网络行动和结果归因。</a:t>
+              <a:t>分叉点不是数据形态，而是买方还是供应方承担决策、动作与结果责任。稳定产品、语义、任务适用性和计量只决定服务能否履约，并不解释为什么分化。</a:t>
             </a:r>
           </a:p>
         </p:txBody>
@@ -12117,7 +12117,7 @@
                 <a:latin typeface="WenQuanYi Micro Hei"/>
                 <a:ea typeface="WenQuanYi Micro Hei"/>
               </a:rPr>
-              <a:t>共同基础与成立逻辑</a:t>
+              <a:t>分化机制  ·  决策权 × 动作权 × 结果责任</a:t>
             </a:r>
           </a:p>
         </p:txBody>
@@ -12158,7 +12158,7 @@
                 <a:latin typeface="WenQuanYi Micro Hei"/>
                 <a:ea typeface="WenQuanYi Micro Hei"/>
               </a:rPr>
-              <a:t>内部语义、任务适用性、权限和血缘不稳，API只会把差异暴露给客户。单运营商覆盖通常不足以支撑规模行业应用，必须经聚合层统一发现、认证、行为、用量和清结算。跨组织使用还需持续执行用途、撤销、责任和收入分配。</a:t>
+              <a:t>有集成能力且保留控制权的买方购买可组合能力，形成路径A；希望转移持续运营与结果责任的客户购买托管结果，形成路径B。接口标准化推动A跨网复制，也压低差异化；归因与责任风险限制B规模化，因此两者长期并存。</a:t>
             </a:r>
           </a:p>
         </p:txBody>
@@ -12217,7 +12217,7 @@
         <p:spPr>
           <a:xfrm>
             <a:off x="475488" y="1975104"/>
-            <a:ext cx="1417320" cy="201168"/>
+            <a:ext cx="1645920" cy="201168"/>
           </a:xfrm>
           <a:prstGeom prst="roundRect">
             <a:avLst/>
@@ -12260,7 +12260,7 @@
         <p:spPr>
           <a:xfrm>
             <a:off x="475488" y="1993392"/>
-            <a:ext cx="1417320" cy="182880"/>
+            <a:ext cx="1645920" cy="182880"/>
           </a:xfrm>
           <a:prstGeom prst="rect">
             <a:avLst/>
@@ -12287,7 +12287,7 @@
                 <a:latin typeface="WenQuanYi Micro Hei"/>
                 <a:ea typeface="WenQuanYi Micro Hei"/>
               </a:rPr>
-              <a:t>路径A  ·  可先行</a:t>
+              <a:t>路径A  ·  中高确定性</a:t>
             </a:r>
           </a:p>
         </p:txBody>
@@ -12300,8 +12300,8 @@
         </p:nvSpPr>
         <p:spPr>
           <a:xfrm>
-            <a:off x="1975104" y="1956816"/>
-            <a:ext cx="3895344" cy="237744"/>
+            <a:off x="2212848" y="1956816"/>
+            <a:ext cx="3657600" cy="237744"/>
           </a:xfrm>
           <a:prstGeom prst="rect">
             <a:avLst/>
@@ -12369,7 +12369,7 @@
                 <a:latin typeface="WenQuanYi Micro Hei"/>
                 <a:ea typeface="WenQuanYi Micro Hei"/>
               </a:rPr>
-              <a:t>供给</a:t>
+              <a:t>责任与控制</a:t>
             </a:r>
           </a:p>
         </p:txBody>
@@ -12410,7 +12410,7 @@
                 <a:latin typeface="WenQuanYi Micro Hei"/>
                 <a:ea typeface="WenQuanYi Micro Hei"/>
               </a:rPr>
-              <a:t>Quality on Demand（QoD）、位置、身份、状态、分析服务；标准化网络能力API；最小必要、可撤销的数据产品。</a:t>
+              <a:t>买方保留业务决策和网络动作权；供应方只保证接口行为、可用性、SLA与用途约束，不承担最终业务结果。</a:t>
             </a:r>
           </a:p>
         </p:txBody>
@@ -12451,7 +12451,7 @@
                 <a:latin typeface="WenQuanYi Micro Hei"/>
                 <a:ea typeface="WenQuanYi Micro Hei"/>
               </a:rPr>
-              <a:t>客户 / 计价</a:t>
+              <a:t>交易对象 / 买方</a:t>
             </a:r>
           </a:p>
         </p:txBody>
@@ -12492,7 +12492,7 @@
                 <a:latin typeface="WenQuanYi Micro Hei"/>
                 <a:ea typeface="WenQuanYi Micro Hei"/>
               </a:rPr>
-              <a:t>行业平台、应用开发者、CPaaS和聚合渠道。按调用、会话、覆盖、用量或订阅收费。</a:t>
+              <a:t>Quality on Demand（QoD）、位置、身份、状态、分析或网络能力；面向行业平台、开发者、CPaaS与聚合渠道。</a:t>
             </a:r>
           </a:p>
         </p:txBody>
@@ -12533,7 +12533,7 @@
                 <a:latin typeface="WenQuanYi Micro Hei"/>
                 <a:ea typeface="WenQuanYi Micro Hei"/>
               </a:rPr>
-              <a:t>前置条件</a:t>
+              <a:t>扩张与计价</a:t>
             </a:r>
           </a:p>
         </p:txBody>
@@ -12574,7 +12574,7 @@
                 <a:latin typeface="WenQuanYi Micro Hei"/>
                 <a:ea typeface="WenQuanYi Micro Hei"/>
               </a:rPr>
-              <a:t>内部产品契约、跨运营商行为一致、可追溯外部SLA、用途约束与计量结算。不依赖T4/T5规模化。</a:t>
+              <a:t>聚合层解决跨网发现、认证、覆盖、用量和结算；按调用、会话、覆盖、用量或订阅收费。</a:t>
             </a:r>
           </a:p>
         </p:txBody>
@@ -12615,7 +12615,7 @@
                 <a:latin typeface="WenQuanYi Micro Hei"/>
                 <a:ea typeface="WenQuanYi Micro Hei"/>
               </a:rPr>
-              <a:t>验证</a:t>
+              <a:t>验证 / 反证</a:t>
             </a:r>
           </a:p>
         </p:txBody>
@@ -12656,7 +12656,7 @@
                 <a:latin typeface="WenQuanYi Micro Hei"/>
                 <a:ea typeface="WenQuanYi Micro Hei"/>
               </a:rPr>
-              <a:t>跨网一致、活跃付费客户、调用/会话收入、履约成本、续费。API数量增长但无持续收入即不成立。</a:t>
+              <a:t>验证跨网一致、付费客户、收入、履约成本和续费。只有API数量而无持续消费与收入即不成立。</a:t>
             </a:r>
           </a:p>
         </p:txBody>
@@ -12715,7 +12715,7 @@
         <p:spPr>
           <a:xfrm>
             <a:off x="6291072" y="1975104"/>
-            <a:ext cx="1554480" cy="201168"/>
+            <a:ext cx="1737360" cy="201168"/>
           </a:xfrm>
           <a:prstGeom prst="roundRect">
             <a:avLst/>
@@ -12758,7 +12758,7 @@
         <p:spPr>
           <a:xfrm>
             <a:off x="6291072" y="1993392"/>
-            <a:ext cx="1554480" cy="182880"/>
+            <a:ext cx="1737360" cy="182880"/>
           </a:xfrm>
           <a:prstGeom prst="rect">
             <a:avLst/>
@@ -12785,7 +12785,7 @@
                 <a:latin typeface="WenQuanYi Micro Hei"/>
                 <a:ea typeface="WenQuanYi Micro Hei"/>
               </a:rPr>
-              <a:t>路径B  ·  条件升级</a:t>
+              <a:t>路径B  ·  低—中确定性</a:t>
             </a:r>
           </a:p>
         </p:txBody>
@@ -12798,8 +12798,8 @@
         </p:nvSpPr>
         <p:spPr>
           <a:xfrm>
-            <a:off x="7918704" y="1956816"/>
-            <a:ext cx="3758184" cy="237744"/>
+            <a:off x="8101583" y="1956816"/>
+            <a:ext cx="3575304" cy="237744"/>
           </a:xfrm>
           <a:prstGeom prst="rect">
             <a:avLst/>
@@ -12826,7 +12826,7 @@
                 <a:latin typeface="WenQuanYi Micro Hei"/>
                 <a:ea typeface="WenQuanYi Micro Hei"/>
               </a:rPr>
-              <a:t>结果型自治服务</a:t>
+              <a:t>结果型托管/自治服务</a:t>
             </a:r>
           </a:p>
         </p:txBody>
@@ -12867,7 +12867,7 @@
                 <a:latin typeface="WenQuanYi Micro Hei"/>
                 <a:ea typeface="WenQuanYi Micro Hei"/>
               </a:rPr>
-              <a:t>供给</a:t>
+              <a:t>责任与控制</a:t>
             </a:r>
           </a:p>
         </p:txBody>
@@ -12908,7 +12908,7 @@
                 <a:latin typeface="WenQuanYi Micro Hei"/>
                 <a:ea typeface="WenQuanYi Micro Hei"/>
               </a:rPr>
-              <a:t>网络体验改善、交易成功率提升、风险/损失降低、能耗或运营效率改善。</a:t>
+              <a:t>供应方参与决策和动作，并对约定结果负责；客户购买的是效果和责任转移，而不是单项接口。</a:t>
             </a:r>
           </a:p>
         </p:txBody>
@@ -12949,7 +12949,7 @@
                 <a:latin typeface="WenQuanYi Micro Hei"/>
                 <a:ea typeface="WenQuanYi Micro Hei"/>
               </a:rPr>
-              <a:t>客户 / 计价</a:t>
+              <a:t>交易对象 / 买方</a:t>
             </a:r>
           </a:p>
         </p:txBody>
@@ -12990,7 +12990,7 @@
                 <a:latin typeface="WenQuanYi Micro Hei"/>
                 <a:ea typeface="WenQuanYi Micro Hei"/>
               </a:rPr>
-              <a:t>金融、车联、工业、媒体等结果责任方。按效果增益、风险降低、业务量或结果分成。</a:t>
+              <a:t>体验、成功率、节能、故障或风险改善；面向金融、车联、工业、媒体等结果责任方。</a:t>
             </a:r>
           </a:p>
         </p:txBody>
@@ -13031,7 +13031,7 @@
                 <a:latin typeface="WenQuanYi Micro Hei"/>
                 <a:ea typeface="WenQuanYi Micro Hei"/>
               </a:rPr>
-              <a:t>额外条件</a:t>
+              <a:t>扩张与计价</a:t>
             </a:r>
           </a:p>
         </p:txBody>
@@ -13072,7 +13072,7 @@
                 <a:latin typeface="WenQuanYi Micro Hei"/>
                 <a:ea typeface="WenQuanYi Micro Hei"/>
               </a:rPr>
-              <a:t>T4/T5可信行动、结果归因、动作授权、风险暴露上限、失败回退、责任与收益分配。</a:t>
+              <a:t>需T4/T5、结果基线、归因、动作授权、风险上限和回滚；按托管费、增益、风险降低或结果分成。</a:t>
             </a:r>
           </a:p>
         </p:txBody>
@@ -13113,7 +13113,7 @@
                 <a:latin typeface="WenQuanYi Micro Hei"/>
                 <a:ea typeface="WenQuanYi Micro Hei"/>
               </a:rPr>
-              <a:t>验证</a:t>
+              <a:t>验证 / 反证</a:t>
             </a:r>
           </a:p>
         </p:txBody>
@@ -13154,7 +13154,7 @@
                 <a:latin typeface="WenQuanYi Micro Hei"/>
                 <a:ea typeface="WenQuanYi Micro Hei"/>
               </a:rPr>
-              <a:t>结果归因、误动作、风险暴露、责任争议、回滚成本和效果分成。无法归因、定责或回退即不能规模化。</a:t>
+              <a:t>验证归因置信、效果、误动作、风险、争议和回滚成本。无法定义基线、定责或回退即不能规模化。</a:t>
             </a:r>
           </a:p>
         </p:txBody>
@@ -13240,7 +13240,7 @@
                 <a:latin typeface="WenQuanYi Micro Hei"/>
                 <a:ea typeface="WenQuanYi Micro Hei"/>
               </a:rPr>
-              <a:t>领先信号</a:t>
+              <a:t>长期共存</a:t>
             </a:r>
           </a:p>
         </p:txBody>
@@ -13281,7 +13281,7 @@
                 <a:latin typeface="WenQuanYi Micro Hei"/>
                 <a:ea typeface="WenQuanYi Micro Hei"/>
               </a:rPr>
-              <a:t>路径A出现持续付费与跨网结算；路径B把动作证据和效果责任写入合同，并明确结果基线、观测窗口和作用域。</a:t>
+              <a:t>能自行集成的客户购买能力，希望转移运营责任的客户购买结果；A和B不是简单成熟度先后，收入、责任和风险必须分开核算。</a:t>
             </a:r>
           </a:p>
         </p:txBody>
@@ -13363,7 +13363,7 @@
                 <a:latin typeface="WenQuanYi Micro Hei"/>
                 <a:ea typeface="WenQuanYi Micro Hei"/>
               </a:rPr>
-              <a:t>路径A：CAMARA/Open Gateway、TM Forum Operate API、聚合渠道和中国移动Quality on Demand（QoD）商用已有信号。路径B：规模付费、结果责任和归因机制公开证据不足。</a:t>
+              <a:t>A：CAMARA/Open Gateway与中国移动Quality on Demand（QoD）已提供商业信号。B：域级自动化有效，但公开结果定价、责任转移和规模分成证据不足。</a:t>
             </a:r>
           </a:p>
         </p:txBody>
@@ -13404,7 +13404,7 @@
                 <a:latin typeface="WenQuanYi Micro Hei"/>
                 <a:ea typeface="WenQuanYi Micro Hei"/>
               </a:rPr>
-              <a:t>边界</a:t>
+              <a:t>共同前提 / 边界</a:t>
             </a:r>
           </a:p>
         </p:txBody>
@@ -13445,7 +13445,7 @@
                 <a:latin typeface="WenQuanYi Micro Hei"/>
                 <a:ea typeface="WenQuanYi Micro Hei"/>
               </a:rPr>
-              <a:t>原始感知数据出售不是默认模式。内部效率价值不等于外部商业收入。两条路径应分别核算收入、责任和履约成本。</a:t>
+              <a:t>内部产品稳定性只决定能否履约，不是分化原因。原始感知数据出售不是默认模式；域级性能改善也不能外推结果型合同已成立。</a:t>
             </a:r>
           </a:p>
         </p:txBody>

</xml_diff>

<commit_message>
Regenerate expanded section 3 deck and enforce density target
Co-authored-by: newmanxiang <newmanxiang@users.noreply.github.com>
</commit_message>
<xml_diff>
--- a/reports/6g-data-fabric-section-3-deck.pptx
+++ b/reports/6g-data-fabric-section-3-deck.pptx
@@ -3321,7 +3321,7 @@
                 <a:latin typeface="WenQuanYi Micro Hei"/>
                 <a:ea typeface="WenQuanYi Micro Hei"/>
               </a:rPr>
-              <a:t>四项筛选只决定哪些能力进入T1–T8；趋势之间的关系来自最小前置条件、独立价值和横切范围。因此不是八条平行口号，也不是四级严格串行。</a:t>
+              <a:t>四项筛选只决定哪些能力进入T1–T8；趋势之间的关系来自最小前置条件、独立价值和横切范围。可信供给同时支撑能力服务与自动化，但T4/T5只约束承担动作责任的T7-B；因此不是八条平行口号，也不是四级严格串行。</a:t>
             </a:r>
           </a:p>
         </p:txBody>
@@ -3534,7 +3534,7 @@
                 <a:latin typeface="WenQuanYi Micro Hei"/>
                 <a:ea typeface="WenQuanYi Micro Hei"/>
               </a:rPr>
-              <a:t>问题须由6G物理分布、AI原生、跨域自治和生态开放产生；不解决会持续限制数据使用、动作安全或商业规模。</a:t>
+              <a:t>问题须由6G物理分布、AI原生、跨域自治和生态开放产生；不解决会持续限制数据使用、动作安全或商业规模。只提升功能便利性、没有结构性约束的议题不进入趋势清单。</a:t>
             </a:r>
           </a:p>
         </p:txBody>
@@ -3661,7 +3661,7 @@
                 <a:latin typeface="WenQuanYi Micro Hei"/>
                 <a:ea typeface="WenQuanYi Micro Hei"/>
               </a:rPr>
-              <a:t>必须能设置领先信号、可测试指标和反证条件；否则只是愿景，不能作为趋势判断。</a:t>
+              <a:t>必须能设置领先信号、可测试指标、时间窗和反证条件；否则只是愿景，不能作为趋势判断。每条趋势都要说明何时降级、停止或回到既有机制。</a:t>
             </a:r>
           </a:p>
         </p:txBody>
@@ -3788,7 +3788,7 @@
                 <a:latin typeface="WenQuanYi Micro Hei"/>
                 <a:ea typeface="WenQuanYi Micro Hei"/>
               </a:rPr>
-              <a:t>是否已有组件、原型、参考架构或部署基础，以及可实施的接口、运行时和治理机制。</a:t>
+              <a:t>检查是否已有组件、原型、参考架构或部署基础，以及接口、运行时、治理和运维机制是否可实施。单点功能存在不等于跨域体系成熟。</a:t>
             </a:r>
           </a:p>
         </p:txBody>
@@ -3915,7 +3915,7 @@
                 <a:latin typeface="WenQuanYi Micro Hei"/>
                 <a:ea typeface="WenQuanYi Micro Hei"/>
               </a:rPr>
-              <a:t>标准讨论、厂商投入、客户需求和商业信号是否同向；证据按规范、产品、研究和愿景分档。</a:t>
+              <a:t>标准讨论、厂商投入、客户需求和商业信号是否同向；证据按规范、产品、具名部署、研究和愿景分档，避免把路线图或品牌组合当成已证事实。</a:t>
             </a:r>
           </a:p>
         </p:txBody>
@@ -4146,7 +4146,7 @@
                 <a:latin typeface="WenQuanYi Micro Hei"/>
                 <a:ea typeface="WenQuanYi Micro Hei"/>
               </a:rPr>
-              <a:t>及时可达 × 正确使用，两类能力互为条件、并行建设</a:t>
+              <a:t>及时可达 × 正确使用；共同提供稳定对象、版本、用途和适用性证明，工程上互为条件、并行建设</a:t>
             </a:r>
           </a:p>
         </p:txBody>
@@ -4319,6 +4319,26 @@
               <a:t>数据/API、位置、身份、分析、网络能力</a:t>
             </a:r>
           </a:p>
+          <a:p>
+            <a:pPr algn="l">
+              <a:lnSpc>
+                <a:spcPct val="105000"/>
+              </a:lnSpc>
+              <a:spcAft>
+                <a:spcPts val="100"/>
+              </a:spcAft>
+            </a:pPr>
+            <a:r>
+              <a:rPr sz="1000" b="0">
+                <a:solidFill>
+                  <a:srgbClr val="2C3E50"/>
+                </a:solidFill>
+                <a:latin typeface="WenQuanYi Micro Hei"/>
+                <a:ea typeface="WenQuanYi Micro Hei"/>
+              </a:rPr>
+              <a:t>买方保留决策权与动作权</a:t>
+            </a:r>
+          </a:p>
         </p:txBody>
       </p:sp>
       <p:sp>
@@ -4357,7 +4377,7 @@
                 <a:latin typeface="WenQuanYi Micro Hei"/>
                 <a:ea typeface="WenQuanYi Micro Hei"/>
               </a:rPr>
-              <a:t>不必等待高风险自治成熟，可按调用/会话/覆盖先行收费</a:t>
+              <a:t>不必等待高风险自治成熟，可经聚合层跨网复制，按调用、会话、覆盖、用量或订阅先行收费</a:t>
             </a:r>
           </a:p>
         </p:txBody>
@@ -4588,7 +4608,7 @@
                 <a:latin typeface="WenQuanYi Micro Hei"/>
                 <a:ea typeface="WenQuanYi Micro Hei"/>
               </a:rPr>
-              <a:t>只约束高风险、跨域自治扩权，不否定只读分析和建议</a:t>
+              <a:t>只约束高风险、跨域自治扩权；要求身份、策略、动作证据、风险预算与回滚，不否定只读分析和建议</a:t>
             </a:r>
           </a:p>
         </p:txBody>
@@ -4761,6 +4781,26 @@
               <a:t>体验、交易、风控、运营结果</a:t>
             </a:r>
           </a:p>
+          <a:p>
+            <a:pPr algn="l">
+              <a:lnSpc>
+                <a:spcPct val="105000"/>
+              </a:lnSpc>
+              <a:spcAft>
+                <a:spcPts val="100"/>
+              </a:spcAft>
+            </a:pPr>
+            <a:r>
+              <a:rPr sz="1000" b="0">
+                <a:solidFill>
+                  <a:srgbClr val="2C3E50"/>
+                </a:solidFill>
+                <a:latin typeface="WenQuanYi Micro Hei"/>
+                <a:ea typeface="WenQuanYi Micro Hei"/>
+              </a:rPr>
+              <a:t>供应方承担部分效果责任</a:t>
+            </a:r>
+          </a:p>
         </p:txBody>
       </p:sp>
       <p:sp>
@@ -4799,7 +4839,7 @@
                 <a:latin typeface="WenQuanYi Micro Hei"/>
                 <a:ea typeface="WenQuanYi Micro Hei"/>
               </a:rPr>
-              <a:t>额外依赖T4/T5、结果归因、动作责任和回滚</a:t>
+              <a:t>额外依赖T4/T5、结果基线、因果归因、动作授权和回滚；按托管费、效果增益或结果分成</a:t>
             </a:r>
           </a:p>
         </p:txBody>
@@ -5055,7 +5095,7 @@
                 <a:latin typeface="WenQuanYi Micro Hei"/>
                 <a:ea typeface="WenQuanYi Micro Hei"/>
               </a:rPr>
-              <a:t>不构成第五个演进阶段；增强既有NF、SMO服务、边缘Agent或新功能均可承载同一外部行为。</a:t>
+              <a:t>不构成第五个阶段；增强既有NF、SMO服务、边缘Agent或新功能均可承载同一外部行为。验证重点是互操作、替换成本和额外状态。</a:t>
             </a:r>
           </a:p>
         </p:txBody>
@@ -5220,7 +5260,7 @@
                           <a:latin typeface="WenQuanYi Micro Hei"/>
                           <a:ea typeface="WenQuanYi Micro Hei"/>
                         </a:rPr>
-                        <a:t>需求刚性强，目录、近源处理和产品化已有工程基础</a:t>
+                        <a:t>需求刚性强；目录、事件、近源处理和产品化已有工程基础，主要缺跨产品复用与多厂商对账</a:t>
                       </a:r>
                     </a:p>
                   </a:txBody>
@@ -5294,7 +5334,7 @@
                           <a:latin typeface="WenQuanYi Micro Hei"/>
                           <a:ea typeface="WenQuanYi Micro Hei"/>
                         </a:rPr>
-                        <a:t>机制明确，通信级闭环、动作证据和任务适用性仍需验证</a:t>
+                        <a:t>机制明确；通信级闭环、动作证据、适用性信封与强制准入仍需具名部署验证</a:t>
                       </a:r>
                     </a:p>
                   </a:txBody>
@@ -5368,7 +5408,7 @@
                           <a:latin typeface="WenQuanYi Micro Hei"/>
                           <a:ea typeface="WenQuanYi Micro Hei"/>
                         </a:rPr>
-                        <a:t>能力服务已有CAMARA/Open Gateway信号；结果型服务的归因、责任和规模付费尚不成熟</a:t>
+                        <a:t>A已有CAMARA/Open Gateway付费信号；B的结果基线、归因、责任转移和规模分成尚不成熟</a:t>
                       </a:r>
                     </a:p>
                   </a:txBody>
@@ -5442,7 +5482,7 @@
                           <a:latin typeface="WenQuanYi Micro Hei"/>
                           <a:ea typeface="WenQuanYi Micro Hei"/>
                         </a:rPr>
-                        <a:t>能力收敛方向明确，最终网元和部署拓扑尚未冻结</a:t>
+                        <a:t>能力与接口收敛方向明确；最终网元、职责边界、部署拓扑和互操作规则尚未冻结</a:t>
                       </a:r>
                     </a:p>
                   </a:txBody>
@@ -5828,7 +5868,7 @@
                 <a:latin typeface="WenQuanYi Micro Hei"/>
                 <a:ea typeface="WenQuanYi Micro Hei"/>
               </a:rPr>
-              <a:t>静态目录必然落后于生产状态；高频无线与感知数据又不能默认全量集中。因此必须同时具备变化事件传播和全局规则、近源执行分层。</a:t>
+              <a:t>静态目录必然落后于生产状态；高频无线与感知数据又不能默认全量集中。因此必须同时具备“快照—变化事件—对账”的状态机制，以及“全局定义—近源执行—异步回证”的部署机制；两者共同回答数据是否及时、可定位、可回退。</a:t>
             </a:r>
           </a:p>
         </p:txBody>
@@ -6039,7 +6079,7 @@
                 <a:latin typeface="WenQuanYi Micro Hei"/>
                 <a:ea typeface="WenQuanYi Micro Hei"/>
               </a:rPr>
-              <a:t>完整机制：基线快照 + 变化事件 + 周期对账。事件携带事件时间、版本、来源、作用域、Correlation ID，以及受影响的产品、模型、策略和消费者。</a:t>
+              <a:t>完整机制：基线快照 + 变化事件 + 周期对账。事件携带事件时间、版本、来源、作用域、Correlation ID、变更前后值，以及受影响的产品、模型、缓存、策略和消费者；无法仅靠事件恢复全量状态。</a:t>
             </a:r>
           </a:p>
         </p:txBody>
@@ -6121,7 +6161,7 @@
                 <a:latin typeface="WenQuanYi Micro Hei"/>
                 <a:ea typeface="WenQuanYi Micro Hei"/>
               </a:rPr>
-              <a:t>Schema/对象关系、拓扑与配置、任务适用性与权限、血缘与成本、数据—模型关联。对象覆盖小区、波束、频段、UE群、会话、云资源及其映射。</a:t>
+              <a:t>Schema/对象关系、拓扑与配置、任务适用性与权限、血缘与成本、数据—模型—动作关联。对象覆盖小区、波束、频段、UE群、会话、切片、云资源及跨域映射；每类对象需定义Owner与版本源。</a:t>
             </a:r>
           </a:p>
         </p:txBody>
@@ -6203,7 +6243,7 @@
                 <a:latin typeface="WenQuanYi Micro Hei"/>
                 <a:ea typeface="WenQuanYi Micro Hei"/>
               </a:rPr>
-              <a:t>自动生成影响清单；触发契约测试、缓存/特征/模型失效、策略复核和重新审批；支持跨域变更回放与责任追踪。</a:t>
+              <a:t>自动生成影响清单；触发契约测试、缓存/特征/模型失效、策略复核和重新审批；支持跨域变更回放、延迟传播监测与责任追踪。消费者只订阅与自身作用域相关的变化。</a:t>
             </a:r>
           </a:p>
         </p:txBody>
@@ -6285,7 +6325,7 @@
                 <a:latin typeface="WenQuanYi Micro Hei"/>
                 <a:ea typeface="WenQuanYi Micro Hei"/>
               </a:rPr>
-              <a:t>目录只描述扫描时刻；配置、拓扑、权限和质量持续变化。模型和Agent使用过期信息会把报表错误升级为错误动作。</a:t>
+              <a:t>目录只描述扫描时刻；配置、拓扑、权限和质量持续变化。模型和Agent使用过期信息会把报表错误升级为错误动作；跨接口对象若无统一事件时间与版本，也无法判断先后和影响范围。</a:t>
             </a:r>
           </a:p>
         </p:txBody>
@@ -6367,7 +6407,7 @@
                 <a:latin typeface="WenQuanYi Micro Hei"/>
                 <a:ea typeface="WenQuanYi Micro Hei"/>
               </a:rPr>
-              <a:t>不把全部业务数据改成事件；中央事件总线不进入毫秒快环；事件不能替代本地状态，必须保留快照和对账。</a:t>
+              <a:t>不把全部业务数据改成事件；中央事件总线不进入毫秒快环；事件不能替代本地状态，必须保留快照和周期对账。若事件丢失、乱序或延迟超限，消费者应退回基线或停止自动动作。</a:t>
             </a:r>
           </a:p>
         </p:txBody>
@@ -6578,7 +6618,7 @@
                 <a:latin typeface="WenQuanYi Micro Hei"/>
                 <a:ea typeface="WenQuanYi Micro Hei"/>
               </a:rPr>
-              <a:t>高频数据全量远传受带宽、时延、能耗、隐私和断链约束。快环、MEC、专网与NTN必须本地运行；完全分散又会造成语义、版本和责任漂移。</a:t>
+              <a:t>高频数据全量远传受带宽、时延、能耗、隐私和断链约束。快环、MEC、专网与NTN必须本地运行；完全分散又会造成语义、版本、策略和责任漂移，因此需要逻辑统一而非物理集中。</a:t>
             </a:r>
           </a:p>
         </p:txBody>
@@ -6705,7 +6745,7 @@
                 <a:latin typeface="WenQuanYi Micro Hei"/>
                 <a:ea typeface="WenQuanYi Micro Hei"/>
               </a:rPr>
-              <a:t>对象/语义、任务适用性模板、产品定义、策略、模型和版本发布。统一的是规则与语义，不是全部存储和处理位置。</a:t>
+              <a:t>定义对象/语义、任务适用性模板、产品、策略、模型、权限和版本基线，发布兼容关系与回退规则。统一的是规则、责任和验收口径，不是全部存储与处理位置。</a:t>
             </a:r>
           </a:p>
         </p:txBody>
@@ -6832,7 +6872,7 @@
                 <a:latin typeface="WenQuanYi Micro Hei"/>
                 <a:ea typeface="WenQuanYi Micro Hei"/>
               </a:rPr>
-              <a:t>过滤、聚合、特征、缓存、预编译策略、受限推理与动作；断链期间按已批准版本继续运行。</a:t>
+              <a:t>按资源预算执行过滤、聚合、特征、缓存、预编译策略、受限推理与白名单动作；维护实时状态。断链期间只运行已批准版本，超时或冲突则降级。</a:t>
             </a:r>
           </a:p>
         </p:txBody>
@@ -6959,7 +6999,7 @@
                 <a:latin typeface="WenQuanYi Micro Hei"/>
                 <a:ea typeface="WenQuanYi Micro Hei"/>
               </a:rPr>
-              <a:t>上传摘要、执行证据、漂移与冲突；支持版本回退。远端目录/审批不得成为快环同步依赖。</a:t>
+              <a:t>上传摘要、任务适用性、执行证据、漂移、冲突和资源消耗；支持对账、模型重验与版本回退。远端目录、审批或云模型不得成为快环同步依赖。</a:t>
             </a:r>
           </a:p>
         </p:txBody>
@@ -7000,7 +7040,7 @@
                 <a:latin typeface="WenQuanYi Micro Hei"/>
                 <a:ea typeface="WenQuanYi Micro Hei"/>
               </a:rPr>
-              <a:t>边界：不同网络仍可采用不同层级和拓扑。Ericsson动态放置、Nokia域自治加公共Fabric、Huawei近源算子命名不同，但共同指向两级控制。</a:t>
+              <a:t>边界：不同网络仍可采用不同层级和拓扑。Ericsson强调动态放置，Nokia保留域自治，Huawei提出近源算子；它们共同指向逻辑全局控制与本地确定性执行。</a:t>
             </a:r>
           </a:p>
           <a:p>
@@ -7020,7 +7060,7 @@
                 <a:latin typeface="WenQuanYi Micro Hei"/>
                 <a:ea typeface="WenQuanYi Micro Hei"/>
               </a:rPr>
-              <a:t>趋同的是部署约束，不是统一产品或网元名称。</a:t>
+              <a:t>趋同的是时标、故障域、版本和责任约束，不是统一产品或网元名称。若中心不可达导致本地停摆，或本地长期不回证，两级架构均不成立。</a:t>
             </a:r>
           </a:p>
         </p:txBody>
@@ -7147,7 +7187,7 @@
                 <a:latin typeface="WenQuanYi Micro Hei"/>
                 <a:ea typeface="WenQuanYi Micro Hei"/>
               </a:rPr>
-              <a:t>T2：Schema/配置/任务适用性/权限变更自动生成影响清单并触发CI或策略检查。T3：近源算子与全局目录/策略解耦，断链按已批准版本运行。</a:t>
+              <a:t>T2：Schema/配置/任务适用性/权限变更自动生成影响清单并触发CI、缓存/模型失效或策略检查。T3：近源算子与全局目录/策略解耦，断链按批准版本运行并异步回证。</a:t>
             </a:r>
           </a:p>
         </p:txBody>
@@ -7229,7 +7269,7 @@
                 <a:latin typeface="WenQuanYi Micro Hei"/>
                 <a:ea typeface="WenQuanYi Micro Hei"/>
               </a:rPr>
-              <a:t>T2：变更发现P95、影响覆盖、误报/漏报、对账差异、失效传播时长。T3：P99、跨域字节减量、断链可用、策略同步、版本回退。</a:t>
+              <a:t>T2：发现P95、事件丢失/乱序、影响覆盖、误报漏报、对账差异、失效传播。T3：P99、跨域字节减量、断链时长、资源预算、策略同步、证据完整和回退成功。</a:t>
             </a:r>
           </a:p>
         </p:txBody>
@@ -7311,7 +7351,7 @@
                 <a:latin typeface="WenQuanYi Micro Hei"/>
                 <a:ea typeface="WenQuanYi Micro Hei"/>
               </a:rPr>
-              <a:t>T2：目录仍靠人工扫描，事故早于目录发现变化，事件无法关联对象与版本。T3：所有查询/审批必须经过中心，或各域无法共享语义和策略。</a:t>
+              <a:t>T2：目录仍靠人工扫描，事故早于变化发现，事件无法关联对象、版本和消费者。T3：所有查询/审批必须经过中心，本地无降级能力，或长期不回证导致全局状态失真。</a:t>
             </a:r>
           </a:p>
         </p:txBody>
@@ -7687,7 +7727,7 @@
                 <a:latin typeface="WenQuanYi Micro Hei"/>
                 <a:ea typeface="WenQuanYi Micro Hei"/>
               </a:rPr>
-              <a:t>数据可访问不等于可使用。持续复用需要Owner、契约和生命周期；进入模型与闭环还需要面向特定对象、时间和任务的任务适用性证明。</a:t>
+              <a:t>数据可访问不等于可复用，更不等于可进入模型或闭环。持续供给需要Owner、契约、版本、成本和退出机制；机器消费还必须证明数据对当前对象、时空、配置和任务适用，并在条件变化时重新验收。</a:t>
             </a:r>
           </a:p>
         </p:txBody>
@@ -7898,7 +7938,7 @@
                 <a:latin typeface="WenQuanYi Micro Hei"/>
                 <a:ea typeface="WenQuanYi Micro Hei"/>
               </a:rPr>
-              <a:t>最低定义：明确消费者与任务、稳定标识和版本、Owner、Schema/语义、任务适用性、SLO、用途/权限、血缘、成本/计量、保留期及退出机制。只有目录条目、接口包装或Marketplace页面，仍不是数据产品。</a:t>
+              <a:t>最低定义：明确消费者与任务、稳定标识和版本、Owner、Schema/语义、任务适用性、SLO、用途/权限、血缘、成本/计量、保留期、降级与退出机制；同时给出变更通知和兼容策略。只有目录条目、接口包装或Marketplace页面，仍不是数据产品。</a:t>
             </a:r>
           </a:p>
         </p:txBody>
@@ -7980,7 +8020,7 @@
                 <a:latin typeface="WenQuanYi Micro Hei"/>
                 <a:ea typeface="WenQuanYi Micro Hei"/>
               </a:rPr>
-              <a:t>源和消费者同时增加，点对点集成按“源×消费者”增长。稳定契约是跨场景复用的必要条件；无Owner就无法持续管理变更、SLO、成本和退出。</a:t>
+              <a:t>源和消费者同时增加，点对点集成按“源×消费者”增长；同一数据若被重复采集、清洗和解释，边际成本不会下降。稳定契约是跨场景复用前提；无Owner就无法管理变更、SLO、成本、争议和退出。</a:t>
             </a:r>
           </a:p>
         </p:txBody>
@@ -8062,7 +8102,7 @@
                 <a:latin typeface="WenQuanYi Micro Hei"/>
                 <a:ea typeface="WenQuanYi Micro Hei"/>
               </a:rPr>
-              <a:t>优先产品化故障、节能、移动性、QoE和模型特征。默认交付事件、聚合指标、特征或分析服务，而不是全量原始流。</a:t>
+              <a:t>优先产品化故障、节能、移动性、QoE和模型特征等高复用数据族。默认交付事件、聚合指标、特征或分析服务，而非全量原始流；每项产品绑定权威源、用途、消费者和责任人。</a:t>
             </a:r>
           </a:p>
         </p:txBody>
@@ -8144,7 +8184,7 @@
                 <a:latin typeface="WenQuanYi Micro Hei"/>
                 <a:ea typeface="WenQuanYi Micro Hei"/>
               </a:rPr>
-              <a:t>以持续消费者、跨场景复用、契约合规和单位有效任务成本验收，不以目录数量、接口数量或PB规模验收。</a:t>
+              <a:t>以持续消费者、第二场景/后端复用、交付周期、契约违规、重复采集下降和单位有效任务成本验收；同时核算生产、存储、跨域传输和退出成本，不以目录、接口或PB数量验收。</a:t>
             </a:r>
           </a:p>
         </p:txBody>
@@ -8226,7 +8266,7 @@
                 <a:latin typeface="WenQuanYi Micro Hei"/>
                 <a:ea typeface="WenQuanYi Micro Hei"/>
               </a:rPr>
-              <a:t>产品化不等于上架目录。无线数据必须携带小区、频段、波束、配置和采样窗口，不能只交付字段。</a:t>
+              <a:t>产品化不等于上架目录。无线数据必须携带小区、频段、波束、配置、采样窗口和测量条件，不能只交付字段；长期无人消费、无版本承诺或无法退出的条目应下架。</a:t>
             </a:r>
           </a:p>
         </p:txBody>
@@ -8437,7 +8477,7 @@
                 <a:latin typeface="WenQuanYi Micro Hei"/>
                 <a:ea typeface="WenQuanYi Micro Hei"/>
               </a:rPr>
-              <a:t>任务适用性指面向特定用途的数据适用性质量，不是覆盖所有数据的总分，也不是已冻结的统一3GPP指标。它用可测试的“适用性信封”说明：数据在何种对象、时空、配置与采样条件下可被哪个模型或闭环安全使用。</a:t>
+              <a:t>任务适用性（Data Fitness for Use）不是数据的统一总分或既定3GPP指标，而是可测试的“适用性信封”：说明数据在何种对象、时空、配置、采样和误差条件下，可被哪个模型、Agent或闭环安全使用；条件变化后必须重新验证。</a:t>
             </a:r>
           </a:p>
         </p:txBody>
@@ -8564,7 +8604,7 @@
                 <a:latin typeface="WenQuanYi Micro Hei"/>
                 <a:ea typeface="WenQuanYi Micro Hei"/>
               </a:rPr>
-              <a:t>准确、完整、一致、新鲜、唯一、可追溯。</a:t>
+              <a:t>准确、完整、一致、新鲜、唯一、可追溯；明确缺失、重复、异常值和来源可信度。</a:t>
             </a:r>
           </a:p>
         </p:txBody>
@@ -8691,7 +8731,7 @@
                 <a:latin typeface="WenQuanYi Micro Hei"/>
                 <a:ea typeface="WenQuanYi Micro Hei"/>
               </a:rPr>
-              <a:t>采样代表性、时空覆盖、同步误差、配置一致、测量置信、suspect/incomplete。</a:t>
+              <a:t>采样代表性、时空覆盖、同步误差、配置一致、测量置信、suspect/incomplete；区分网络状态与采集链路误差。</a:t>
             </a:r>
           </a:p>
         </p:txBody>
@@ -8818,7 +8858,7 @@
                 <a:latin typeface="WenQuanYi Micro Hei"/>
                 <a:ea typeface="WenQuanYi Micro Hei"/>
               </a:rPr>
-              <a:t>标签来源、训练—服务分布偏差、特征漂移、适用对象与禁用边界。</a:t>
+              <a:t>标签来源、训练—服务分布偏差、特征漂移、适用对象、模型版本和禁用边界；避免历史高质量掩盖当前失配。</a:t>
             </a:r>
           </a:p>
         </p:txBody>
@@ -8945,7 +8985,7 @@
                 <a:latin typeface="WenQuanYi Micro Hei"/>
                 <a:ea typeface="WenQuanYi Micro Hei"/>
               </a:rPr>
-              <a:t>按用途设阈值；未达则降级、阻断或重验；与模型卡、产品契约和动作风险挂钩。</a:t>
+              <a:t>按用途和动作风险设阈值；未达则降级、补采、阻断或重验，并与模型卡、产品契约、策略审批和动作放行挂钩。</a:t>
             </a:r>
           </a:p>
         </p:txBody>
@@ -8986,7 +9026,7 @@
                 <a:latin typeface="WenQuanYi Micro Hei"/>
                 <a:ea typeface="WenQuanYi Micro Hei"/>
               </a:rPr>
-              <a:t>边界：字段完整不等于语义可比；样本量大不等于具有代表性。不能用一个总分评价所有数据。术语上不以QoD指代数据质量；QoD仅指CAMARA Quality on Demand API。</a:t>
+              <a:t>边界：字段完整不等于语义可比；样本量大不等于具有代表性；离线合格不等于当前网络状态可用。不能用一个总分评价测量、告警、位置、感知和训练特征。术语上不以QoD指代数据质量；QoD仅指CAMARA Quality on Demand API。</a:t>
             </a:r>
           </a:p>
         </p:txBody>
@@ -9113,7 +9153,7 @@
                 <a:latin typeface="WenQuanYi Micro Hei"/>
                 <a:ea typeface="WenQuanYi Micro Hei"/>
               </a:rPr>
-              <a:t>T1：产品契约进入版本基线，生产者和消费者共同签署SLO/任务适用性。T6：任务适用性进入数据契约、模型卡、跨域接口和动作放行条件。</a:t>
+              <a:t>T1：契约进入版本基线，生产者与消费者共同签署SLO/适用性并管理退出。T6：适用性进入契约、模型卡、接口、重验触发器和动作放行条件。</a:t>
             </a:r>
           </a:p>
         </p:txBody>
@@ -9195,7 +9235,7 @@
                 <a:latin typeface="WenQuanYi Micro Hei"/>
                 <a:ea typeface="WenQuanYi Micro Hei"/>
               </a:rPr>
-              <a:t>T1：交付周期、复用消费者、契约违规、重复采集下降、单位任务成本。T6：覆盖/代表性、同步误差、配置一致、漂移、误动作、降级触发。</a:t>
+              <a:t>T1：交付周期、复用消费者、第二场景、违规、重复采集下降、单位任务成本。T6：覆盖/代表性、同步误差、配置一致、漂移、误动作、降级与重验触发。</a:t>
             </a:r>
           </a:p>
         </p:txBody>
@@ -9277,7 +9317,7 @@
                 <a:latin typeface="WenQuanYi Micro Hei"/>
                 <a:ea typeface="WenQuanYi Micro Hei"/>
               </a:rPr>
-              <a:t>反证：每场景重新取数清洗，或只统计完整性/接口成功率。证据：Nokia Data Suite、Ericsson Data Mesh、Huawei Data QoS。</a:t>
+              <a:t>反证：每场景重复取数清洗、产品长期无人消费，或只报完整性/接口成功率。证据：Nokia Data Suite、Ericsson Data Mesh、Huawei Data QoS仅支持机制方向，非统一标准。</a:t>
             </a:r>
           </a:p>
         </p:txBody>
@@ -9653,7 +9693,7 @@
                 <a:latin typeface="WenQuanYi Micro Hei"/>
                 <a:ea typeface="WenQuanYi Micro Hei"/>
               </a:rPr>
-              <a:t>数据进入真实网络控制后，错误不再只是分析偏差。融合的是接口与证据图，分离的是治理责任；NDT是重要放行证据，不是绝对安全证明。</a:t>
+              <a:t>数据进入真实网络控制后，错误会转化为资源、SLA和安全风险。可信自动化必须把供数、决策、验证、执行和结果串成可审计责任链，同时分离数据、模型、Agent和域控制器职责；NDT提供反事实证据，但不能替代授权和责任审批。</a:t>
             </a:r>
           </a:p>
         </p:txBody>
@@ -9778,7 +9818,7 @@
                 <a:latin typeface="WenQuanYi Micro Hei"/>
                 <a:ea typeface="WenQuanYi Micro Hei"/>
               </a:rPr>
-              <a:t>版本化产品、上下文、任务适用性、策略</a:t>
+              <a:t>版本化产品、上下文、任务适用性、用途与策略</a:t>
             </a:r>
           </a:p>
         </p:txBody>
@@ -9946,7 +9986,7 @@
                 <a:latin typeface="WenQuanYi Micro Hei"/>
                 <a:ea typeface="WenQuanYi Micro Hei"/>
               </a:rPr>
-              <a:t>模型/Agent选择数据、工具和候选动作</a:t>
+              <a:t>模型/Agent记录输入、推理、工具和候选动作</a:t>
             </a:r>
           </a:p>
         </p:txBody>
@@ -10114,7 +10154,7 @@
                 <a:latin typeface="WenQuanYi Micro Hei"/>
                 <a:ea typeface="WenQuanYi Micro Hei"/>
               </a:rPr>
-              <a:t>NDT预演、策略、风险预算</a:t>
+              <a:t>NDT预演、策略冲突、风险预算与审批</a:t>
             </a:r>
           </a:p>
         </p:txBody>
@@ -10282,7 +10322,7 @@
                 <a:latin typeface="WenQuanYi Micro Hei"/>
                 <a:ea typeface="WenQuanYi Micro Hei"/>
               </a:rPr>
-              <a:t>身份、作用域、租约、灰度</a:t>
+              <a:t>身份、作用域、租约、白名单、灰度与熔断</a:t>
             </a:r>
           </a:p>
         </p:txBody>
@@ -10450,7 +10490,7 @@
                 <a:latin typeface="WenQuanYi Micro Hei"/>
                 <a:ea typeface="WenQuanYi Micro Hei"/>
               </a:rPr>
-              <a:t>结果、漂移、熔断、回滚</a:t>
+              <a:t>结果、KPI、副作用、漂移、接管与回滚</a:t>
             </a:r>
           </a:p>
         </p:txBody>
@@ -10661,7 +10701,7 @@
                 <a:latin typeface="WenQuanYi Micro Hei"/>
                 <a:ea typeface="WenQuanYi Micro Hei"/>
               </a:rPr>
-              <a:t>Agent若处理真实网络任务，必须持续获得当前对象、配置、质量与权限，而不是一次性把文档放进向量库。一旦能调用工具，数据错误就会转化为动作风险。</a:t>
+              <a:t>Agent若处理真实网络任务，必须持续获得当前对象、配置、任务适用性、权限和作用域，而不是一次性把文档放进向量库。一旦能调用工具，数据错误、模型漂移和过期策略都会转化为动作风险。</a:t>
             </a:r>
           </a:p>
         </p:txBody>
@@ -10743,7 +10783,7 @@
                 <a:latin typeface="WenQuanYi Micro Hei"/>
                 <a:ea typeface="WenQuanYi Micro Hei"/>
               </a:rPr>
-              <a:t>目录检索、订阅、血缘和策略成为受控工具；数据、模型、提示、工具、动作和结果共享版本关系；审计证据跨工具传播。</a:t>
+              <a:t>目录检索、订阅、血缘、任务适用性和策略成为受控工具；数据、模型、提示、工具、动作和结果共享版本与Correlation ID；审计证据跨工具、域和人工接管过程传播。</a:t>
             </a:r>
           </a:p>
         </p:txBody>
@@ -10825,7 +10865,7 @@
                 <a:latin typeface="WenQuanYi Micro Hei"/>
                 <a:ea typeface="WenQuanYi Micro Hei"/>
               </a:rPr>
-              <a:t>数据管用途/保留/删除；模型管性能/偏差/漂移；Agent管身份/权限/动作。Reasoner与Actor隔离，无边界“大脑”不可审计。</a:t>
+              <a:t>数据Owner管用途、质量、保留和删除；模型Owner管性能、偏差和漂移；Agent管身份、权限和动作；域控制器保留实时状态与执行责任。Reasoner与Actor隔离，无边界“大脑”不可审计。</a:t>
             </a:r>
           </a:p>
         </p:txBody>
@@ -10907,7 +10947,7 @@
                 <a:latin typeface="WenQuanYi Micro Hei"/>
                 <a:ea typeface="WenQuanYi Micro Hei"/>
               </a:rPr>
-              <a:t>只读检索与调查 → 决策建议与工单编排 → 影子运行 → 白名单低风险动作 → 高风险动作受控准入。快环保留确定性执行。</a:t>
+              <a:t>只读检索与调查 → 决策建议与工单编排 → 历史回放/影子运行 → 白名单低风险动作 → 高风险动作受控准入。每级明确证据门槛、超时降级和人工接管；快环保留确定性执行。</a:t>
             </a:r>
           </a:p>
         </p:txBody>
@@ -11118,7 +11158,7 @@
                 <a:latin typeface="WenQuanYi Micro Hei"/>
                 <a:ea typeface="WenQuanYi Micro Hei"/>
               </a:rPr>
-              <a:t>Data Fabric向NDT提供带时间、配置、任务适用性与血缘的版本化状态快照；NDT比较执行/不执行/替代动作，输出收益、冲突和副作用；策略引擎决定放行、灰度或拒绝，生产结果再回流校准。</a:t>
+              <a:t>Data Fabric向NDT提供带时间、配置、任务适用性、策略和血缘的版本化状态快照；NDT比较执行、不执行及替代动作，输出收益、冲突、副作用和置信边界；策略引擎据此放行、灰度或拒绝，生产结果再回流校准场景与误差。</a:t>
             </a:r>
           </a:p>
         </p:txBody>
@@ -11200,7 +11240,7 @@
                 <a:latin typeface="WenQuanYi Micro Hei"/>
                 <a:ea typeface="WenQuanYi Micro Hei"/>
               </a:rPr>
-              <a:t>定义保真度、最大同步滞后、场景覆盖和可接受预测误差；保存输入快照、孪生/模型版本、候选动作、预演结果、放行理由和生产结果。</a:t>
+              <a:t>按动作类别定义保真度、最大同步滞后、场景覆盖、可接受误差和未知状态；保存输入快照、拓扑/配置、孪生与模型版本、候选动作、预演结果、放行理由和生产结果。</a:t>
             </a:r>
           </a:p>
         </p:txBody>
@@ -11282,7 +11322,7 @@
                 <a:latin typeface="WenQuanYi Micro Hei"/>
                 <a:ea typeface="WenQuanYi Micro Hei"/>
               </a:rPr>
-              <a:t>误差超门槛或覆盖不足时自动退回建议/人工模式。不得用“孪生通过”替代责任审批。</a:t>
+              <a:t>误差、滞后或场景覆盖超门槛时，自动缩小作用域、降低风险预算或退回建议/人工模式；不得用“孪生通过”替代责任审批，也不能把离线准确率直接当生产安全。</a:t>
             </a:r>
           </a:p>
         </p:txBody>
@@ -11364,7 +11404,7 @@
                 <a:latin typeface="WenQuanYi Micro Hei"/>
                 <a:ea typeface="WenQuanYi Micro Hei"/>
               </a:rPr>
-              <a:t>NDT是证据链中的消费者和生产者，不是Fabric同义词，也不是绝对安全证明。必须与灰度、熔断、回滚和人工接管组合。</a:t>
+              <a:t>NDT是证据链中的消费者和生产者，不是Fabric同义词，也不是绝对安全证明。必须与策略、灰度、熔断、回滚、人工接管和生产校准组合；低风险动作可采用更轻量证据。</a:t>
             </a:r>
           </a:p>
         </p:txBody>
@@ -11491,7 +11531,7 @@
                 <a:latin typeface="WenQuanYi Micro Hei"/>
                 <a:ea typeface="WenQuanYi Micro Hei"/>
               </a:rPr>
-              <a:t>Agent工具调用携带身份、产品/模型版本和策略决策；NDT进入变更审批和动作验证路径，而不是独立演示平台。</a:t>
+              <a:t>Agent工具调用携带身份、作用域、租约、产品/模型/策略版本和Correlation ID；NDT进入变更审批、影子运行和动作验证，而不是独立演示平台。</a:t>
             </a:r>
           </a:p>
         </p:txBody>
@@ -11573,7 +11613,7 @@
                 <a:latin typeface="WenQuanYi Micro Hei"/>
                 <a:ea typeface="WenQuanYi Micro Hei"/>
               </a:rPr>
-              <a:t>证据完整、越权拦截、错误上下文阻断、人工接管、回滚成功；同步滞后、预测误差、覆盖、回放一致、灰度失败。</a:t>
+              <a:t>证据完整、越权拦截、错误上下文阻断、人工接管、回滚成功；同步滞后、预测误差、场景覆盖、回放一致、灰度失败、副作用与校准偏差。</a:t>
             </a:r>
           </a:p>
         </p:txBody>
@@ -11655,7 +11695,7 @@
                 <a:latin typeface="WenQuanYi Micro Hei"/>
                 <a:ea typeface="WenQuanYi Micro Hei"/>
               </a:rPr>
-              <a:t>反证：只有聊天或RAG；NDT只有拓扑可视化。证据：3GPP AI生命周期、SA5 NDT管理、厂商Agent与自治平台。</a:t>
+              <a:t>反证：只有聊天/RAG或工单建议；工具调用无法追责；NDT只有拓扑可视化、无误差门槛和生产反馈。证据：3GPP AI生命周期、SA5 NDT管理及厂商自治平台仅证明积木正在形成。</a:t>
             </a:r>
           </a:p>
         </p:txBody>
@@ -12031,7 +12071,7 @@
                 <a:latin typeface="WenQuanYi Micro Hei"/>
                 <a:ea typeface="WenQuanYi Micro Hei"/>
               </a:rPr>
-              <a:t>分叉点不是数据形态，而是买方还是供应方承担决策、动作与结果责任。稳定产品、语义、任务适用性和计量只决定服务能否履约，并不解释为什么分化。</a:t>
+              <a:t>分叉点不是数据形态，而是买方还是供应方承担决策、动作与结果责任。稳定产品、语义、任务适用性和计量只决定服务能否履约，并不解释为什么分化；客户集成能力、风险偏好和责任转移需求决定交易结构。</a:t>
             </a:r>
           </a:p>
         </p:txBody>
@@ -12158,7 +12198,7 @@
                 <a:latin typeface="WenQuanYi Micro Hei"/>
                 <a:ea typeface="WenQuanYi Micro Hei"/>
               </a:rPr>
-              <a:t>有集成能力且保留控制权的买方购买可组合能力，形成路径A；希望转移持续运营与结果责任的客户购买托管结果，形成路径B。接口标准化推动A跨网复制，也压低差异化；归因与责任风险限制B规模化，因此两者长期并存。</a:t>
+              <a:t>有集成能力且保留控制权的买方购买可组合能力，形成A；希望转移持续运营与结果责任的客户购买托管结果，形成B。接口标准化推动A跨网复制，也降低单项能力稀缺性；归因、授权和责任风险限制B规模化，因此两者长期并存而非先后替代。</a:t>
             </a:r>
           </a:p>
         </p:txBody>
@@ -12410,7 +12450,7 @@
                 <a:latin typeface="WenQuanYi Micro Hei"/>
                 <a:ea typeface="WenQuanYi Micro Hei"/>
               </a:rPr>
-              <a:t>买方保留业务决策和网络动作权；供应方只保证接口行为、可用性、SLA与用途约束，不承担最终业务结果。</a:t>
+              <a:t>买方保留业务决策、能力组合和网络动作权；供应方只保证接口行为、可用性、SLA、用途与撤销，不承担最终业务结果。故障时按能力SLA赔付，不对下游业务全责。</a:t>
             </a:r>
           </a:p>
         </p:txBody>
@@ -12492,7 +12532,7 @@
                 <a:latin typeface="WenQuanYi Micro Hei"/>
                 <a:ea typeface="WenQuanYi Micro Hei"/>
               </a:rPr>
-              <a:t>Quality on Demand（QoD）、位置、身份、状态、分析或网络能力；面向行业平台、开发者、CPaaS与聚合渠道。</a:t>
+              <a:t>Quality on Demand（QoD）、位置、身份、状态、分析或网络能力；面向有集成能力的行业平台、开发者、CPaaS与聚合渠道。原始感知流不是默认商品。</a:t>
             </a:r>
           </a:p>
         </p:txBody>
@@ -12574,7 +12614,7 @@
                 <a:latin typeface="WenQuanYi Micro Hei"/>
                 <a:ea typeface="WenQuanYi Micro Hei"/>
               </a:rPr>
-              <a:t>聚合层解决跨网发现、认证、覆盖、用量和结算；按调用、会话、覆盖、用量或订阅收费。</a:t>
+              <a:t>聚合层解决跨网发现、认证、覆盖、行为一致、用量和清结算；按调用、会话、覆盖、用量或订阅收费。接口越标准，复制越快，但差异化和单价可能下降。</a:t>
             </a:r>
           </a:p>
         </p:txBody>
@@ -12656,7 +12696,7 @@
                 <a:latin typeface="WenQuanYi Micro Hei"/>
                 <a:ea typeface="WenQuanYi Micro Hei"/>
               </a:rPr>
-              <a:t>验证跨网一致、付费客户、收入、履约成本和续费。只有API数量而无持续消费与收入即不成立。</a:t>
+              <a:t>验证跨网一致、开发者复用、活跃付费客户、收入、履约成本、失败率和续费。只有API数量、一次性试用或补贴调用而无持续收入即不成立。</a:t>
             </a:r>
           </a:p>
         </p:txBody>
@@ -12908,7 +12948,7 @@
                 <a:latin typeface="WenQuanYi Micro Hei"/>
                 <a:ea typeface="WenQuanYi Micro Hei"/>
               </a:rPr>
-              <a:t>供应方参与决策和动作，并对约定结果负责；客户购买的是效果和责任转移，而不是单项接口。</a:t>
+              <a:t>供应方参与数据选择、策略决策和网络动作，并对约定结果负责；客户购买效果与运营责任转移，而不是单项接口。合同必须限定作用域、可控因素和责任上限。</a:t>
             </a:r>
           </a:p>
         </p:txBody>
@@ -12990,7 +13030,7 @@
                 <a:latin typeface="WenQuanYi Micro Hei"/>
                 <a:ea typeface="WenQuanYi Micro Hei"/>
               </a:rPr>
-              <a:t>体验、成功率、节能、故障或风险改善；面向金融、车联、工业、媒体等结果责任方。</a:t>
+              <a:t>体验、交易成功率、节能、故障率、运营成本或风险改善；面向缺少持续集成/运营能力、愿意转移部分责任的金融、车联、工业和媒体客户。</a:t>
             </a:r>
           </a:p>
         </p:txBody>
@@ -13072,7 +13112,7 @@
                 <a:latin typeface="WenQuanYi Micro Hei"/>
                 <a:ea typeface="WenQuanYi Micro Hei"/>
               </a:rPr>
-              <a:t>需T4/T5、结果基线、归因、动作授权、风险上限和回滚；按托管费、增益、风险降低或结果分成。</a:t>
+              <a:t>需T4/T5、结果基线、对照组/观测窗口、因果归因、动作授权、风险上限和回滚；按托管费、业务量、效果增益、风险降低或结果分成。</a:t>
             </a:r>
           </a:p>
         </p:txBody>
@@ -13154,7 +13194,7 @@
                 <a:latin typeface="WenQuanYi Micro Hei"/>
                 <a:ea typeface="WenQuanYi Micro Hei"/>
               </a:rPr>
-              <a:t>验证归因置信、效果、误动作、风险、争议和回滚成本。无法定义基线、定责或回退即不能规模化。</a:t>
+              <a:t>验证归因置信、净效果、误动作、风险暴露、责任争议、人工接管和回滚成本。无法定义基线、排除外因、定责或回退即不能规模化。</a:t>
             </a:r>
           </a:p>
         </p:txBody>
@@ -13281,7 +13321,7 @@
                 <a:latin typeface="WenQuanYi Micro Hei"/>
                 <a:ea typeface="WenQuanYi Micro Hei"/>
               </a:rPr>
-              <a:t>能自行集成的客户购买能力，希望转移运营责任的客户购买结果；A和B不是简单成熟度先后，收入、责任和风险必须分开核算。</a:t>
+              <a:t>有集成能力的客户购买能力，希望转移运营责任的客户购买结果；A和B不是成熟度先后。A可成为B的输入，B也可把部分能力重新开放，但收入、责任、风险和成本必须分账。</a:t>
             </a:r>
           </a:p>
         </p:txBody>
@@ -13363,7 +13403,7 @@
                 <a:latin typeface="WenQuanYi Micro Hei"/>
                 <a:ea typeface="WenQuanYi Micro Hei"/>
               </a:rPr>
-              <a:t>A：CAMARA/Open Gateway与中国移动Quality on Demand（QoD）已提供商业信号。B：域级自动化有效，但公开结果定价、责任转移和规模分成证据不足。</a:t>
+              <a:t>A：CAMARA/Open Gateway、聚合渠道和中国移动Quality on Demand（QoD）已有具名商业信号。B：stc/KDDI/Indosat证明域级自动化有效，但公开结果定价、责任转移和规模分成合同不足。</a:t>
             </a:r>
           </a:p>
         </p:txBody>
@@ -13445,7 +13485,7 @@
                 <a:latin typeface="WenQuanYi Micro Hei"/>
                 <a:ea typeface="WenQuanYi Micro Hei"/>
               </a:rPr>
-              <a:t>内部产品稳定性只决定能否履约，不是分化原因。原始感知数据出售不是默认模式；域级性能改善也不能外推结果型合同已成立。</a:t>
+              <a:t>内部产品稳定性、语义、适用性、权限和计量只决定能否履约，不是分化原因。原始感知数据出售不是默认模式；域级性能改善不能自动外推结果型合同成立。</a:t>
             </a:r>
           </a:p>
         </p:txBody>
@@ -13821,7 +13861,7 @@
                 <a:latin typeface="WenQuanYi Micro Hei"/>
                 <a:ea typeface="WenQuanYi Micro Hei"/>
               </a:rPr>
-              <a:t>T1–T7的需求会留下，承载它们的拓扑、组件边界和名称未必统一。跨厂商必须一致的是外部行为；内部组件和部署位置仍可保持多样化。</a:t>
+              <a:t>T1–T7的需求会留下，但承载它们的拓扑、组件边界和名称未必统一。标准应先冻结跨厂商必须一致的角色、对象、能力语义、生命周期、接口行为和测试；实现可继续由既有功能增强、管理服务、边缘Agent或新NF组合。</a:t>
             </a:r>
           </a:p>
         </p:txBody>
@@ -14032,7 +14072,7 @@
                 <a:latin typeface="WenQuanYi Micro Hei"/>
                 <a:ea typeface="WenQuanYi Micro Hei"/>
               </a:rPr>
-              <a:t>生产者、消费者和处理能力角色</a:t>
+              <a:t>生产者、消费者、处理者角色及其责任与错误返回</a:t>
             </a:r>
           </a:p>
         </p:txBody>
@@ -14157,7 +14197,7 @@
                 <a:latin typeface="WenQuanYi Micro Hei"/>
                 <a:ea typeface="WenQuanYi Micro Hei"/>
               </a:rPr>
-              <a:t>稳定对象标识、对象关系和信息模型</a:t>
+              <a:t>稳定对象标识、权威源、对象关系、版本和信息模型</a:t>
             </a:r>
           </a:p>
         </p:txBody>
@@ -14282,7 +14322,7 @@
                 <a:latin typeface="WenQuanYi Micro Hei"/>
                 <a:ea typeface="WenQuanYi Micro Hei"/>
               </a:rPr>
-              <a:t>任务适用性公共属性与表达方式</a:t>
+              <a:t>任务适用性公共属性、单位、作用域、置信和表达方式</a:t>
             </a:r>
           </a:p>
         </p:txBody>
@@ -14407,7 +14447,7 @@
                 <a:latin typeface="WenQuanYi Micro Hei"/>
                 <a:ea typeface="WenQuanYi Micro Hei"/>
               </a:rPr>
-              <a:t>发现、处理、存储、交付和暴露的外部行为</a:t>
+              <a:t>发现、处理、存储、订阅、交付和暴露的外部行为</a:t>
             </a:r>
           </a:p>
         </p:txBody>
@@ -14532,7 +14572,7 @@
                 <a:latin typeface="WenQuanYi Micro Hei"/>
                 <a:ea typeface="WenQuanYi Micro Hei"/>
               </a:rPr>
-              <a:t>生命周期、授权和证据引用关系</a:t>
+              <a:t>生命周期、授权、撤销、审计和证据引用关系</a:t>
             </a:r>
           </a:p>
         </p:txBody>
@@ -14657,7 +14697,7 @@
                 <a:latin typeface="WenQuanYi Micro Hei"/>
                 <a:ea typeface="WenQuanYi Micro Hei"/>
               </a:rPr>
-              <a:t>跨厂商一致性测试</a:t>
+              <a:t>跨厂商一致性、故障、降级、迁移和替换测试</a:t>
             </a:r>
           </a:p>
         </p:txBody>
@@ -14870,7 +14910,7 @@
                 <a:latin typeface="WenQuanYi Micro Hei"/>
                 <a:ea typeface="WenQuanYi Micro Hei"/>
               </a:rPr>
-              <a:t>扩展DCCF、ADRF、NWDAF、MDA等SBI与管理服务。</a:t>
+              <a:t>扩展DCCF、ADRF、NWDAF、MDA等SBI与管理服务，复用既有鉴权、容灾和运维体系；适合渐进演进。</a:t>
             </a:r>
           </a:p>
         </p:txBody>
@@ -14997,7 +15037,7 @@
                 <a:latin typeface="WenQuanYi Micro Hei"/>
                 <a:ea typeface="WenQuanYi Micro Hei"/>
               </a:rPr>
-              <a:t>以SMO服务、边缘Agent或近源运行时组合部署。</a:t>
+              <a:t>以SMO服务、边缘Agent或近源运行时组合部署；按时标和故障域拆分，不把远端平台放进快环同步路径。</a:t>
             </a:r>
           </a:p>
         </p:txBody>
@@ -15124,7 +15164,7 @@
                 <a:latin typeface="WenQuanYi Micro Hei"/>
                 <a:ea typeface="WenQuanYi Micro Hei"/>
               </a:rPr>
-              <a:t>事件、流、文件、模型和派生数据可选择不同运行时。</a:t>
+              <a:t>事件、流、文件、特征、模型和派生数据可选择不同运行时；核心元数据、契约与证据应可导出迁移。</a:t>
             </a:r>
           </a:p>
         </p:txBody>
@@ -15251,7 +15291,7 @@
                 <a:latin typeface="WenQuanYi Micro Hei"/>
                 <a:ea typeface="WenQuanYi Micro Hei"/>
               </a:rPr>
-              <a:t>仅当复用造成隔离、吞吐或职责不可分时再引入专用功能。</a:t>
+              <a:t>仅当复用造成隔离、吞吐、移动性、状态或职责不可分时引入专用功能，并证明收益覆盖新增复杂度。</a:t>
             </a:r>
           </a:p>
         </p:txBody>
@@ -15378,7 +15418,7 @@
                 <a:latin typeface="WenQuanYi Micro Hei"/>
                 <a:ea typeface="WenQuanYi Micro Hei"/>
               </a:rPr>
-              <a:t>发现、采集、处理、存储、暴露和治理跨越不同域与时标，不同用例不可能共享完全相同的在线流程。标准应优先冻结跨厂商必须一致的外部行为；内部拓扑写得越死，越难适配运营商存量和边缘资源差异。</a:t>
+              <a:t>发现、采集、处理、存储、暴露和治理跨越不同域、时标、故障域与主权边界，不同用例不可能共享完全相同的在线流程。标准应优先冻结可观察的外部行为；内部拓扑写得越死，越难适配存量、边缘资源和多厂商演进。</a:t>
             </a:r>
           </a:p>
           <a:p>
@@ -15398,7 +15438,7 @@
                 <a:latin typeface="WenQuanYi Micro Hei"/>
                 <a:ea typeface="WenQuanYi Micro Hei"/>
               </a:rPr>
-              <a:t>产品跟踪能力、语义、任务适用性、接口和测试，不押注某个厂商网元名称。若独立平面增加时延、状态和重复治理，应退回能力增强；若复用导致职责不可分，再考虑新功能。</a:t>
+              <a:t>产品跟踪能力、语义、任务适用性、接口和测试，不押注厂商网元名。若独立平面增加时延、状态、容灾和重复治理，应退回能力增强；若复用导致职责、隔离或性能不可分，再考虑新功能并设置退出门。</a:t>
             </a:r>
           </a:p>
         </p:txBody>
@@ -15525,7 +15565,7 @@
                 <a:latin typeface="WenQuanYi Micro Hei"/>
                 <a:ea typeface="WenQuanYi Micro Hei"/>
               </a:rPr>
-              <a:t>Rel-21收敛功能、信息模型与接口，同时允许多种部署拓扑。指标：互操作、复用率、额外时延/状态、迁移与替换成本。</a:t>
+              <a:t>Rel-21收敛角色、能力、信息模型、接口和一致性测试，同时允许多种部署。指标：跨厂商互操作、复用、故障降级、额外时延/状态、迁移、后端与运行时替换成本。</a:t>
             </a:r>
           </a:p>
         </p:txBody>
@@ -15607,7 +15647,7 @@
                 <a:latin typeface="WenQuanYi Micro Hei"/>
                 <a:ea typeface="WenQuanYi Micro Hei"/>
               </a:rPr>
-              <a:t>反证：3GPP明确冻结独立统一数据平面及必选NF和流程。证据：SA2 KI#21、SA5 DMFW、Huawei DO/DA/DCP仍是候选原型。</a:t>
+              <a:t>反证：3GPP冻结独立统一数据平面及必选NF/流程，或既有功能在相同约束下无法满足。现有SA2 KI#21、SA5 DMFW及Huawei原型只支持能力研究，未证明唯一拓扑。</a:t>
             </a:r>
           </a:p>
         </p:txBody>
@@ -15689,7 +15729,7 @@
                 <a:latin typeface="WenQuanYi Micro Hei"/>
                 <a:ea typeface="WenQuanYi Micro Hei"/>
               </a:rPr>
-              <a:t>6G Data Fabric的核心控制点将集中于语义、任务适用性、近源运行、动作证据和跨网结算，而不是单一平台名称。</a:t>
+              <a:t>长期控制点集中于语义、任务适用性、近源运行、动作证据、责任合同和跨网结算。平台地位取决于外部契约与互操作，而不是单一名称或数据集中规模。</a:t>
             </a:r>
           </a:p>
         </p:txBody>

</xml_diff>